<commit_message>
feat: double Phase 1 pricing and update payment terms to result-based
</commit_message>
<xml_diff>
--- a/posts/aurora_internal_ai_assistant_proposal_slides.pptx
+++ b/posts/aurora_internal_ai_assistant_proposal_slides.pptx
@@ -3617,31 +3617,6 @@
           </a:p>
         </p:txBody>
       </p:sp>
-      <p:sp>
-        <p:nvSpPr>
-          <p:cNvPr id="4" name="Date Placeholder 3"/>
-          <p:cNvSpPr>
-            <a:spLocks noGrp="1"/>
-          </p:cNvSpPr>
-          <p:nvPr>
-            <p:ph idx="10" sz="half" type="dt"/>
-          </p:nvPr>
-        </p:nvSpPr>
-        <p:spPr/>
-        <p:txBody>
-          <a:bodyPr/>
-          <a:lstStyle/>
-          <a:p>
-            <a:pPr lvl="0" indent="0" marL="0">
-              <a:buNone/>
-            </a:pPr>
-            <a:r>
-              <a:rPr/>
-              <a:t>2026-06-28</a:t>
-            </a:r>
-          </a:p>
-        </p:txBody>
-      </p:sp>
     </p:spTree>
   </p:cSld>
 </p:sld>
@@ -3705,8 +3680,8 @@
         </p:blipFill>
         <p:spPr bwMode="auto">
           <a:xfrm>
-            <a:off x="3365500" y="1193800"/>
-            <a:ext cx="2413000" cy="2882900"/>
+            <a:off x="914400" y="1193800"/>
+            <a:ext cx="7315200" cy="2882900"/>
           </a:xfrm>
           <a:prstGeom prst="rect">
             <a:avLst/>
@@ -3812,8 +3787,8 @@
         </p:blipFill>
         <p:spPr bwMode="auto">
           <a:xfrm>
-            <a:off x="457200" y="2247900"/>
-            <a:ext cx="8229600" cy="762000"/>
+            <a:off x="3556000" y="1193800"/>
+            <a:ext cx="2032000" cy="2882900"/>
           </a:xfrm>
           <a:prstGeom prst="rect">
             <a:avLst/>
@@ -4029,7 +4004,7 @@
             </a:pPr>
             <a:r>
               <a:rPr/>
-              <a:t>4. Phased Delivery Plan</a:t>
+              <a:t>Phased Delivery Plan</a:t>
             </a:r>
           </a:p>
         </p:txBody>
@@ -4066,7 +4041,12 @@
             <p:ph type="title"/>
           </p:nvPr>
         </p:nvSpPr>
-        <p:spPr/>
+        <p:spPr>
+          <a:xfrm>
+            <a:off x="457201" y="204787"/>
+            <a:ext cx="3008313" cy="871538"/>
+          </a:xfrm>
+        </p:spPr>
         <p:txBody>
           <a:bodyPr/>
           <a:lstStyle/>
@@ -4083,12 +4063,12 @@
       </p:sp>
       <p:sp>
         <p:nvSpPr>
-          <p:cNvPr id="3" name="Content Placeholder 2"/>
-          <p:cNvSpPr>
-            <a:spLocks noGrp="1"/>
-          </p:cNvSpPr>
-          <p:nvPr>
-            <p:ph idx="1"/>
+          <p:cNvPr id="4" name="Text Placeholder 3"/>
+          <p:cNvSpPr>
+            <a:spLocks noGrp="1"/>
+          </p:cNvSpPr>
+          <p:nvPr>
+            <p:ph idx="2" sz="half" type="body"/>
           </p:nvPr>
         </p:nvSpPr>
         <p:spPr/>
@@ -4124,8 +4104,8 @@
         </p:blipFill>
         <p:spPr bwMode="auto">
           <a:xfrm>
-            <a:off x="457200" y="1854200"/>
-            <a:ext cx="8229600" cy="1574800"/>
+            <a:off x="3568700" y="1879600"/>
+            <a:ext cx="5105400" cy="520700"/>
           </a:xfrm>
           <a:prstGeom prst="rect">
             <a:avLst/>
@@ -4146,8 +4126,8 @@
         </p:nvSpPr>
         <p:spPr>
           <a:xfrm>
-            <a:off x="457200" y="4076700"/>
-            <a:ext cx="8229600" cy="508000"/>
+            <a:off x="3568700" y="4076700"/>
+            <a:ext cx="5105400" cy="508000"/>
           </a:xfrm>
           <a:prstGeom prst="rect">
             <a:avLst/>
@@ -4200,7 +4180,12 @@
             <p:ph type="title"/>
           </p:nvPr>
         </p:nvSpPr>
-        <p:spPr/>
+        <p:spPr>
+          <a:xfrm>
+            <a:off x="457201" y="204787"/>
+            <a:ext cx="3008313" cy="871538"/>
+          </a:xfrm>
+        </p:spPr>
         <p:txBody>
           <a:bodyPr/>
           <a:lstStyle/>
@@ -4217,12 +4202,12 @@
       </p:sp>
       <p:sp>
         <p:nvSpPr>
-          <p:cNvPr id="3" name="Content Placeholder 2"/>
-          <p:cNvSpPr>
-            <a:spLocks noGrp="1"/>
-          </p:cNvSpPr>
-          <p:nvPr>
-            <p:ph idx="1"/>
+          <p:cNvPr id="4" name="Text Placeholder 3"/>
+          <p:cNvSpPr>
+            <a:spLocks noGrp="1"/>
+          </p:cNvSpPr>
+          <p:nvPr>
+            <p:ph idx="2" sz="half" type="body"/>
           </p:nvPr>
         </p:nvSpPr>
         <p:spPr/>
@@ -4258,8 +4243,8 @@
         </p:blipFill>
         <p:spPr bwMode="auto">
           <a:xfrm>
-            <a:off x="457200" y="1638300"/>
-            <a:ext cx="8229600" cy="1993900"/>
+            <a:off x="3568700" y="1879600"/>
+            <a:ext cx="5105400" cy="520700"/>
           </a:xfrm>
           <a:prstGeom prst="rect">
             <a:avLst/>
@@ -4280,8 +4265,8 @@
         </p:nvSpPr>
         <p:spPr>
           <a:xfrm>
-            <a:off x="457200" y="4076700"/>
-            <a:ext cx="8229600" cy="508000"/>
+            <a:off x="3568700" y="4076700"/>
+            <a:ext cx="5105400" cy="508000"/>
           </a:xfrm>
           <a:prstGeom prst="rect">
             <a:avLst/>
@@ -4365,8 +4350,8 @@
         </p:blipFill>
         <p:spPr bwMode="auto">
           <a:xfrm>
-            <a:off x="4178300" y="1193800"/>
-            <a:ext cx="787400" cy="2882900"/>
+            <a:off x="457200" y="1282700"/>
+            <a:ext cx="8229600" cy="2717800"/>
           </a:xfrm>
           <a:prstGeom prst="rect">
             <a:avLst/>
@@ -4456,7 +4441,7 @@
             </a:pPr>
             <a:r>
               <a:rPr/>
-              <a:t>5. Financial &amp; Scoping Comparison</a:t>
+              <a:t>Financial &amp; Scoping Comparison</a:t>
             </a:r>
           </a:p>
         </p:txBody>
@@ -4529,13 +4514,13 @@
                 <a:tableStyleId>{5C22544A-7EE6-4342-B048-85BDC9FD1C3A}</a:tableStyleId>
               </a:tblPr>
               <a:tblGrid>
-                <a:gridCol w="1168400"/>
-                <a:gridCol w="1168400"/>
-                <a:gridCol w="1168400"/>
-                <a:gridCol w="1168400"/>
-                <a:gridCol w="1168400"/>
-                <a:gridCol w="1168400"/>
-                <a:gridCol w="1168400"/>
+                <a:gridCol w="850900"/>
+                <a:gridCol w="850900"/>
+                <a:gridCol w="850900"/>
+                <a:gridCol w="1422400"/>
+                <a:gridCol w="1422400"/>
+                <a:gridCol w="1422400"/>
+                <a:gridCol w="1422400"/>
               </a:tblGrid>
               <a:tr h="0">
                 <a:tc>
@@ -4722,7 +4707,7 @@
                       </a:pPr>
                       <a:r>
                         <a:rPr b="1"/>
-                        <a:t>$310</a:t>
+                        <a:t>$620</a:t>
                       </a:r>
                     </a:p>
                   </a:txBody>
@@ -4737,7 +4722,7 @@
                       </a:pPr>
                       <a:r>
                         <a:rPr b="1"/>
-                        <a:t>1,138</a:t>
+                        <a:t>2,276</a:t>
                       </a:r>
                     </a:p>
                   </a:txBody>
@@ -4752,7 +4737,7 @@
                       </a:pPr>
                       <a:r>
                         <a:rPr/>
-                        <a:t>~96–98%</a:t>
+                        <a:t>~92–95%</a:t>
                       </a:r>
                     </a:p>
                   </a:txBody>
@@ -4829,7 +4814,7 @@
                       </a:pPr>
                       <a:r>
                         <a:rPr b="1"/>
-                        <a:t>$360</a:t>
+                        <a:t>$720</a:t>
                       </a:r>
                     </a:p>
                   </a:txBody>
@@ -4844,7 +4829,7 @@
                       </a:pPr>
                       <a:r>
                         <a:rPr b="1"/>
-                        <a:t>1,322</a:t>
+                        <a:t>2,644</a:t>
                       </a:r>
                     </a:p>
                   </a:txBody>
@@ -4859,7 +4844,7 @@
                       </a:pPr>
                       <a:r>
                         <a:rPr/>
-                        <a:t>~95–97%</a:t>
+                        <a:t>~91–95%</a:t>
                       </a:r>
                     </a:p>
                   </a:txBody>
@@ -4936,7 +4921,7 @@
                       </a:pPr>
                       <a:r>
                         <a:rPr b="1"/>
-                        <a:t>$670</a:t>
+                        <a:t>$1,340</a:t>
                       </a:r>
                     </a:p>
                   </a:txBody>
@@ -4951,7 +4936,7 @@
                       </a:pPr>
                       <a:r>
                         <a:rPr b="1"/>
-                        <a:t>2,460</a:t>
+                        <a:t>4,920</a:t>
                       </a:r>
                     </a:p>
                   </a:txBody>
@@ -4966,7 +4951,7 @@
                       </a:pPr>
                       <a:r>
                         <a:rPr b="1"/>
-                        <a:t>~96%</a:t>
+                        <a:t>~91–95%</a:t>
                       </a:r>
                     </a:p>
                   </a:txBody>
@@ -5079,7 +5064,7 @@
             </a:pPr>
             <a:r>
               <a:rPr/>
-              <a:t>1. Executive Summary</a:t>
+              <a:t>Executive Summary</a:t>
             </a:r>
           </a:p>
         </p:txBody>
@@ -5152,13 +5137,13 @@
                 <a:tableStyleId>{5C22544A-7EE6-4342-B048-85BDC9FD1C3A}</a:tableStyleId>
               </a:tblPr>
               <a:tblGrid>
-                <a:gridCol w="1168400"/>
-                <a:gridCol w="1168400"/>
-                <a:gridCol w="1168400"/>
-                <a:gridCol w="1168400"/>
-                <a:gridCol w="1168400"/>
-                <a:gridCol w="1168400"/>
-                <a:gridCol w="1168400"/>
+                <a:gridCol w="850900"/>
+                <a:gridCol w="850900"/>
+                <a:gridCol w="850900"/>
+                <a:gridCol w="1422400"/>
+                <a:gridCol w="1422400"/>
+                <a:gridCol w="1422400"/>
+                <a:gridCol w="1422400"/>
               </a:tblGrid>
               <a:tr h="0">
                 <a:tc>
@@ -5804,11 +5789,11 @@
                 <a:tableStyleId>{5C22544A-7EE6-4342-B048-85BDC9FD1C3A}</a:tableStyleId>
               </a:tblPr>
               <a:tblGrid>
-                <a:gridCol w="1016000"/>
-                <a:gridCol w="1016000"/>
-                <a:gridCol w="1016000"/>
-                <a:gridCol w="1016000"/>
-                <a:gridCol w="1016000"/>
+                <a:gridCol w="800100"/>
+                <a:gridCol w="800100"/>
+                <a:gridCol w="1346200"/>
+                <a:gridCol w="1346200"/>
+                <a:gridCol w="800100"/>
               </a:tblGrid>
               <a:tr h="0">
                 <a:tc>
@@ -6476,7 +6461,7 @@
             </a:pPr>
             <a:r>
               <a:rPr/>
-              <a:t>6. Security, Compliance &amp; Setup</a:t>
+              <a:t>Security, Compliance &amp; Setup</a:t>
             </a:r>
           </a:p>
         </p:txBody>
@@ -6544,8 +6529,8 @@
         </p:blipFill>
         <p:spPr bwMode="auto">
           <a:xfrm>
-            <a:off x="1993900" y="1193800"/>
-            <a:ext cx="5168900" cy="2882900"/>
+            <a:off x="1066800" y="1193800"/>
+            <a:ext cx="7023100" cy="2882900"/>
           </a:xfrm>
           <a:prstGeom prst="rect">
             <a:avLst/>
@@ -7071,7 +7056,7 @@
             </a:pPr>
             <a:r>
               <a:rPr/>
-              <a:t>7. Next Steps</a:t>
+              <a:t>Next Steps</a:t>
             </a:r>
           </a:p>
         </p:txBody>
@@ -7108,7 +7093,12 @@
             <p:ph type="title"/>
           </p:nvPr>
         </p:nvSpPr>
-        <p:spPr/>
+        <p:spPr>
+          <a:xfrm>
+            <a:off x="457201" y="204787"/>
+            <a:ext cx="3008313" cy="871538"/>
+          </a:xfrm>
+        </p:spPr>
         <p:txBody>
           <a:bodyPr/>
           <a:lstStyle/>
@@ -7125,12 +7115,12 @@
       </p:sp>
       <p:sp>
         <p:nvSpPr>
-          <p:cNvPr id="3" name="Content Placeholder 2"/>
-          <p:cNvSpPr>
-            <a:spLocks noGrp="1"/>
-          </p:cNvSpPr>
-          <p:nvPr>
-            <p:ph idx="1"/>
+          <p:cNvPr id="4" name="Text Placeholder 3"/>
+          <p:cNvSpPr>
+            <a:spLocks noGrp="1"/>
+          </p:cNvSpPr>
+          <p:nvPr>
+            <p:ph idx="2" sz="half" type="body"/>
           </p:nvPr>
         </p:nvSpPr>
         <p:spPr/>
@@ -7167,7 +7157,7 @@
             </a:r>
             <a:r>
               <a:rPr/>
-              <a:t>: 30% upfront ($201) / 30% at MVP ($201) / 40% at Launch ($268).</a:t>
+              <a:t>: 0% upfront (infra/tools direct) / 50% at MVP ($670 / 2,460 AED) / 50% at Launch ($670 / 2,460 AED).</a:t>
             </a:r>
           </a:p>
         </p:txBody>
@@ -7188,8 +7178,8 @@
         </p:blipFill>
         <p:spPr bwMode="auto">
           <a:xfrm>
-            <a:off x="457200" y="2247900"/>
-            <a:ext cx="8229600" cy="762000"/>
+            <a:off x="3568700" y="1701800"/>
+            <a:ext cx="5105400" cy="876300"/>
           </a:xfrm>
           <a:prstGeom prst="rect">
             <a:avLst/>
@@ -7210,8 +7200,8 @@
         </p:nvSpPr>
         <p:spPr>
           <a:xfrm>
-            <a:off x="457200" y="4076700"/>
-            <a:ext cx="8229600" cy="508000"/>
+            <a:off x="3568700" y="4076700"/>
+            <a:ext cx="5105400" cy="508000"/>
           </a:xfrm>
           <a:prstGeom prst="rect">
             <a:avLst/>
@@ -7303,7 +7293,7 @@
             </a:r>
             <a:r>
               <a:rPr/>
-              <a:t> and confirm budget ($670 Phase 1).</a:t>
+              <a:t> and confirm budget ($1,340 Phase 1).</a:t>
             </a:r>
           </a:p>
           <a:p>
@@ -7526,8 +7516,8 @@
         </p:blipFill>
         <p:spPr bwMode="auto">
           <a:xfrm>
-            <a:off x="1663700" y="1193800"/>
-            <a:ext cx="5816600" cy="2882900"/>
+            <a:off x="1651000" y="1193800"/>
+            <a:ext cx="5854700" cy="2882900"/>
           </a:xfrm>
           <a:prstGeom prst="rect">
             <a:avLst/>
@@ -7617,7 +7607,7 @@
             </a:pPr>
             <a:r>
               <a:rPr/>
-              <a:t>2. What the Team Will See</a:t>
+              <a:t>What the Team Will See</a:t>
             </a:r>
           </a:p>
         </p:txBody>
@@ -7692,7 +7682,7 @@
                 <a:latin typeface="Courier"/>
               </a:rPr>
               <a:t>┌──────────────────────────────────────────────────────────────────┐
-│  🔒 Aurora AI Assistant                      Svetlana A. (Admin) │
+│  🔒 Aurora AI Assistant                                (Admin) │
 │  ───────────────────────────────────────────────────────────────  │
 │  👤 Can we recover VAT on a hotel invoice for a business trip?   │
 │                                                                   │
@@ -7875,7 +7865,7 @@
             </a:pPr>
             <a:r>
               <a:rPr/>
-              <a:t>3. Technical Architecture</a:t>
+              <a:t>Technical Architecture</a:t>
             </a:r>
           </a:p>
         </p:txBody>
@@ -7943,8 +7933,8 @@
         </p:blipFill>
         <p:spPr bwMode="auto">
           <a:xfrm>
-            <a:off x="457200" y="2133600"/>
-            <a:ext cx="8229600" cy="990600"/>
+            <a:off x="3797300" y="1193800"/>
+            <a:ext cx="1562100" cy="2882900"/>
           </a:xfrm>
           <a:prstGeom prst="rect">
             <a:avLst/>

</xml_diff>

<commit_message>
feat: adjust Phase 1 pricing to 1440 USD total and update presentation
</commit_message>
<xml_diff>
--- a/posts/aurora_internal_ai_assistant_proposal_slides.pptx
+++ b/posts/aurora_internal_ai_assistant_proposal_slides.pptx
@@ -4707,7 +4707,7 @@
                       </a:pPr>
                       <a:r>
                         <a:rPr b="1"/>
-                        <a:t>$620</a:t>
+                        <a:t>$720</a:t>
                       </a:r>
                     </a:p>
                   </a:txBody>
@@ -4722,7 +4722,7 @@
                       </a:pPr>
                       <a:r>
                         <a:rPr b="1"/>
-                        <a:t>2,276</a:t>
+                        <a:t>2,644</a:t>
                       </a:r>
                     </a:p>
                   </a:txBody>
@@ -4737,7 +4737,7 @@
                       </a:pPr>
                       <a:r>
                         <a:rPr/>
-                        <a:t>~92–95%</a:t>
+                        <a:t>~90–95%</a:t>
                       </a:r>
                     </a:p>
                   </a:txBody>
@@ -4921,7 +4921,7 @@
                       </a:pPr>
                       <a:r>
                         <a:rPr b="1"/>
-                        <a:t>$1,340</a:t>
+                        <a:t>$1,440</a:t>
                       </a:r>
                     </a:p>
                   </a:txBody>
@@ -4936,7 +4936,7 @@
                       </a:pPr>
                       <a:r>
                         <a:rPr b="1"/>
-                        <a:t>4,920</a:t>
+                        <a:t>5,288</a:t>
                       </a:r>
                     </a:p>
                   </a:txBody>
@@ -4951,7 +4951,7 @@
                       </a:pPr>
                       <a:r>
                         <a:rPr b="1"/>
-                        <a:t>~91–95%</a:t>
+                        <a:t>~90–95%</a:t>
                       </a:r>
                     </a:p>
                   </a:txBody>
@@ -7157,7 +7157,7 @@
             </a:r>
             <a:r>
               <a:rPr/>
-              <a:t>: 0% upfront (infra/tools direct) / 50% at MVP ($670 / 2,460 AED) / 50% at Launch ($670 / 2,460 AED).</a:t>
+              <a:t>: 0% upfront (infra/tools direct) / 50% at MVP ($720 / 2,644 AED) / 50% at Launch ($720 / 2,644 AED).</a:t>
             </a:r>
           </a:p>
         </p:txBody>
@@ -7293,7 +7293,7 @@
             </a:r>
             <a:r>
               <a:rPr/>
-              <a:t> and confirm budget ($1,340 Phase 1).</a:t>
+              <a:t> and confirm budget ($1,440 Phase 1).</a:t>
             </a:r>
           </a:p>
           <a:p>

</xml_diff>

<commit_message>
feat: restore original slide deck styling and update pricing
</commit_message>
<xml_diff>
--- a/posts/aurora_internal_ai_assistant_proposal_slides.pptx
+++ b/posts/aurora_internal_ai_assistant_proposal_slides.pptx
@@ -3617,6 +3617,31 @@
           </a:p>
         </p:txBody>
       </p:sp>
+      <p:sp>
+        <p:nvSpPr>
+          <p:cNvPr id="4" name="Date Placeholder 3"/>
+          <p:cNvSpPr>
+            <a:spLocks noGrp="1"/>
+          </p:cNvSpPr>
+          <p:nvPr>
+            <p:ph idx="10" sz="half" type="dt"/>
+          </p:nvPr>
+        </p:nvSpPr>
+        <p:spPr/>
+        <p:txBody>
+          <a:bodyPr/>
+          <a:lstStyle/>
+          <a:p>
+            <a:pPr lvl="0" indent="0" marL="0">
+              <a:buNone/>
+            </a:pPr>
+            <a:r>
+              <a:rPr/>
+              <a:t>2026-06-28</a:t>
+            </a:r>
+          </a:p>
+        </p:txBody>
+      </p:sp>
     </p:spTree>
   </p:cSld>
 </p:sld>
@@ -3680,8 +3705,8 @@
         </p:blipFill>
         <p:spPr bwMode="auto">
           <a:xfrm>
-            <a:off x="914400" y="1193800"/>
-            <a:ext cx="7315200" cy="2882900"/>
+            <a:off x="3365500" y="1193800"/>
+            <a:ext cx="2413000" cy="2882900"/>
           </a:xfrm>
           <a:prstGeom prst="rect">
             <a:avLst/>
@@ -3787,8 +3812,8 @@
         </p:blipFill>
         <p:spPr bwMode="auto">
           <a:xfrm>
-            <a:off x="3556000" y="1193800"/>
-            <a:ext cx="2032000" cy="2882900"/>
+            <a:off x="457200" y="2247900"/>
+            <a:ext cx="8229600" cy="762000"/>
           </a:xfrm>
           <a:prstGeom prst="rect">
             <a:avLst/>
@@ -4004,7 +4029,7 @@
             </a:pPr>
             <a:r>
               <a:rPr/>
-              <a:t>Phased Delivery Plan</a:t>
+              <a:t>4. Phased Delivery Plan</a:t>
             </a:r>
           </a:p>
         </p:txBody>
@@ -4041,12 +4066,7 @@
             <p:ph type="title"/>
           </p:nvPr>
         </p:nvSpPr>
-        <p:spPr>
-          <a:xfrm>
-            <a:off x="457201" y="204787"/>
-            <a:ext cx="3008313" cy="871538"/>
-          </a:xfrm>
-        </p:spPr>
+        <p:spPr/>
         <p:txBody>
           <a:bodyPr/>
           <a:lstStyle/>
@@ -4063,12 +4083,12 @@
       </p:sp>
       <p:sp>
         <p:nvSpPr>
-          <p:cNvPr id="4" name="Text Placeholder 3"/>
-          <p:cNvSpPr>
-            <a:spLocks noGrp="1"/>
-          </p:cNvSpPr>
-          <p:nvPr>
-            <p:ph idx="2" sz="half" type="body"/>
+          <p:cNvPr id="3" name="Content Placeholder 2"/>
+          <p:cNvSpPr>
+            <a:spLocks noGrp="1"/>
+          </p:cNvSpPr>
+          <p:nvPr>
+            <p:ph idx="1"/>
           </p:nvPr>
         </p:nvSpPr>
         <p:spPr/>
@@ -4104,8 +4124,8 @@
         </p:blipFill>
         <p:spPr bwMode="auto">
           <a:xfrm>
-            <a:off x="3568700" y="1879600"/>
-            <a:ext cx="5105400" cy="520700"/>
+            <a:off x="457200" y="1854200"/>
+            <a:ext cx="8229600" cy="1574800"/>
           </a:xfrm>
           <a:prstGeom prst="rect">
             <a:avLst/>
@@ -4126,8 +4146,8 @@
         </p:nvSpPr>
         <p:spPr>
           <a:xfrm>
-            <a:off x="3568700" y="4076700"/>
-            <a:ext cx="5105400" cy="508000"/>
+            <a:off x="457200" y="4076700"/>
+            <a:ext cx="8229600" cy="508000"/>
           </a:xfrm>
           <a:prstGeom prst="rect">
             <a:avLst/>
@@ -4180,12 +4200,7 @@
             <p:ph type="title"/>
           </p:nvPr>
         </p:nvSpPr>
-        <p:spPr>
-          <a:xfrm>
-            <a:off x="457201" y="204787"/>
-            <a:ext cx="3008313" cy="871538"/>
-          </a:xfrm>
-        </p:spPr>
+        <p:spPr/>
         <p:txBody>
           <a:bodyPr/>
           <a:lstStyle/>
@@ -4202,12 +4217,12 @@
       </p:sp>
       <p:sp>
         <p:nvSpPr>
-          <p:cNvPr id="4" name="Text Placeholder 3"/>
-          <p:cNvSpPr>
-            <a:spLocks noGrp="1"/>
-          </p:cNvSpPr>
-          <p:nvPr>
-            <p:ph idx="2" sz="half" type="body"/>
+          <p:cNvPr id="3" name="Content Placeholder 2"/>
+          <p:cNvSpPr>
+            <a:spLocks noGrp="1"/>
+          </p:cNvSpPr>
+          <p:nvPr>
+            <p:ph idx="1"/>
           </p:nvPr>
         </p:nvSpPr>
         <p:spPr/>
@@ -4243,8 +4258,8 @@
         </p:blipFill>
         <p:spPr bwMode="auto">
           <a:xfrm>
-            <a:off x="3568700" y="1879600"/>
-            <a:ext cx="5105400" cy="520700"/>
+            <a:off x="457200" y="1638300"/>
+            <a:ext cx="8229600" cy="1993900"/>
           </a:xfrm>
           <a:prstGeom prst="rect">
             <a:avLst/>
@@ -4265,8 +4280,8 @@
         </p:nvSpPr>
         <p:spPr>
           <a:xfrm>
-            <a:off x="3568700" y="4076700"/>
-            <a:ext cx="5105400" cy="508000"/>
+            <a:off x="457200" y="4076700"/>
+            <a:ext cx="8229600" cy="508000"/>
           </a:xfrm>
           <a:prstGeom prst="rect">
             <a:avLst/>
@@ -4350,8 +4365,8 @@
         </p:blipFill>
         <p:spPr bwMode="auto">
           <a:xfrm>
-            <a:off x="457200" y="1282700"/>
-            <a:ext cx="8229600" cy="2717800"/>
+            <a:off x="4178300" y="1193800"/>
+            <a:ext cx="787400" cy="2882900"/>
           </a:xfrm>
           <a:prstGeom prst="rect">
             <a:avLst/>
@@ -4441,7 +4456,7 @@
             </a:pPr>
             <a:r>
               <a:rPr/>
-              <a:t>Financial &amp; Scoping Comparison</a:t>
+              <a:t>5. Financial &amp; Scoping Comparison</a:t>
             </a:r>
           </a:p>
         </p:txBody>
@@ -4514,13 +4529,13 @@
                 <a:tableStyleId>{5C22544A-7EE6-4342-B048-85BDC9FD1C3A}</a:tableStyleId>
               </a:tblPr>
               <a:tblGrid>
-                <a:gridCol w="850900"/>
-                <a:gridCol w="850900"/>
-                <a:gridCol w="850900"/>
-                <a:gridCol w="1422400"/>
-                <a:gridCol w="1422400"/>
-                <a:gridCol w="1422400"/>
-                <a:gridCol w="1422400"/>
+                <a:gridCol w="1168400"/>
+                <a:gridCol w="1168400"/>
+                <a:gridCol w="1168400"/>
+                <a:gridCol w="1168400"/>
+                <a:gridCol w="1168400"/>
+                <a:gridCol w="1168400"/>
+                <a:gridCol w="1168400"/>
               </a:tblGrid>
               <a:tr h="0">
                 <a:tc>
@@ -5064,7 +5079,7 @@
             </a:pPr>
             <a:r>
               <a:rPr/>
-              <a:t>Executive Summary</a:t>
+              <a:t>1. Executive Summary</a:t>
             </a:r>
           </a:p>
         </p:txBody>
@@ -5137,13 +5152,13 @@
                 <a:tableStyleId>{5C22544A-7EE6-4342-B048-85BDC9FD1C3A}</a:tableStyleId>
               </a:tblPr>
               <a:tblGrid>
-                <a:gridCol w="850900"/>
-                <a:gridCol w="850900"/>
-                <a:gridCol w="850900"/>
-                <a:gridCol w="1422400"/>
-                <a:gridCol w="1422400"/>
-                <a:gridCol w="1422400"/>
-                <a:gridCol w="1422400"/>
+                <a:gridCol w="1168400"/>
+                <a:gridCol w="1168400"/>
+                <a:gridCol w="1168400"/>
+                <a:gridCol w="1168400"/>
+                <a:gridCol w="1168400"/>
+                <a:gridCol w="1168400"/>
+                <a:gridCol w="1168400"/>
               </a:tblGrid>
               <a:tr h="0">
                 <a:tc>
@@ -5789,11 +5804,11 @@
                 <a:tableStyleId>{5C22544A-7EE6-4342-B048-85BDC9FD1C3A}</a:tableStyleId>
               </a:tblPr>
               <a:tblGrid>
-                <a:gridCol w="800100"/>
-                <a:gridCol w="800100"/>
-                <a:gridCol w="1346200"/>
-                <a:gridCol w="1346200"/>
-                <a:gridCol w="800100"/>
+                <a:gridCol w="1016000"/>
+                <a:gridCol w="1016000"/>
+                <a:gridCol w="1016000"/>
+                <a:gridCol w="1016000"/>
+                <a:gridCol w="1016000"/>
               </a:tblGrid>
               <a:tr h="0">
                 <a:tc>
@@ -6461,7 +6476,7 @@
             </a:pPr>
             <a:r>
               <a:rPr/>
-              <a:t>Security, Compliance &amp; Setup</a:t>
+              <a:t>6. Security, Compliance &amp; Setup</a:t>
             </a:r>
           </a:p>
         </p:txBody>
@@ -6529,8 +6544,8 @@
         </p:blipFill>
         <p:spPr bwMode="auto">
           <a:xfrm>
-            <a:off x="1066800" y="1193800"/>
-            <a:ext cx="7023100" cy="2882900"/>
+            <a:off x="1993900" y="1193800"/>
+            <a:ext cx="5168900" cy="2882900"/>
           </a:xfrm>
           <a:prstGeom prst="rect">
             <a:avLst/>
@@ -7056,7 +7071,7 @@
             </a:pPr>
             <a:r>
               <a:rPr/>
-              <a:t>Next Steps</a:t>
+              <a:t>7. Next Steps</a:t>
             </a:r>
           </a:p>
         </p:txBody>
@@ -7093,12 +7108,7 @@
             <p:ph type="title"/>
           </p:nvPr>
         </p:nvSpPr>
-        <p:spPr>
-          <a:xfrm>
-            <a:off x="457201" y="204787"/>
-            <a:ext cx="3008313" cy="871538"/>
-          </a:xfrm>
-        </p:spPr>
+        <p:spPr/>
         <p:txBody>
           <a:bodyPr/>
           <a:lstStyle/>
@@ -7115,12 +7125,12 @@
       </p:sp>
       <p:sp>
         <p:nvSpPr>
-          <p:cNvPr id="4" name="Text Placeholder 3"/>
-          <p:cNvSpPr>
-            <a:spLocks noGrp="1"/>
-          </p:cNvSpPr>
-          <p:nvPr>
-            <p:ph idx="2" sz="half" type="body"/>
+          <p:cNvPr id="3" name="Content Placeholder 2"/>
+          <p:cNvSpPr>
+            <a:spLocks noGrp="1"/>
+          </p:cNvSpPr>
+          <p:nvPr>
+            <p:ph idx="1"/>
           </p:nvPr>
         </p:nvSpPr>
         <p:spPr/>
@@ -7178,8 +7188,8 @@
         </p:blipFill>
         <p:spPr bwMode="auto">
           <a:xfrm>
-            <a:off x="3568700" y="1701800"/>
-            <a:ext cx="5105400" cy="876300"/>
+            <a:off x="457200" y="2247900"/>
+            <a:ext cx="8229600" cy="762000"/>
           </a:xfrm>
           <a:prstGeom prst="rect">
             <a:avLst/>
@@ -7200,8 +7210,8 @@
         </p:nvSpPr>
         <p:spPr>
           <a:xfrm>
-            <a:off x="3568700" y="4076700"/>
-            <a:ext cx="5105400" cy="508000"/>
+            <a:off x="457200" y="4076700"/>
+            <a:ext cx="8229600" cy="508000"/>
           </a:xfrm>
           <a:prstGeom prst="rect">
             <a:avLst/>
@@ -7516,8 +7526,8 @@
         </p:blipFill>
         <p:spPr bwMode="auto">
           <a:xfrm>
-            <a:off x="1651000" y="1193800"/>
-            <a:ext cx="5854700" cy="2882900"/>
+            <a:off x="1663700" y="1193800"/>
+            <a:ext cx="5816600" cy="2882900"/>
           </a:xfrm>
           <a:prstGeom prst="rect">
             <a:avLst/>
@@ -7607,7 +7617,7 @@
             </a:pPr>
             <a:r>
               <a:rPr/>
-              <a:t>What the Team Will See</a:t>
+              <a:t>2. What the Team Will See</a:t>
             </a:r>
           </a:p>
         </p:txBody>
@@ -7682,7 +7692,7 @@
                 <a:latin typeface="Courier"/>
               </a:rPr>
               <a:t>┌──────────────────────────────────────────────────────────────────┐
-│  🔒 Aurora AI Assistant                                (Admin) │
+│  🔒 Aurora AI Assistant                      Svetlana A. (Admin) │
 │  ───────────────────────────────────────────────────────────────  │
 │  👤 Can we recover VAT on a hotel invoice for a business trip?   │
 │                                                                   │
@@ -7865,7 +7875,7 @@
             </a:pPr>
             <a:r>
               <a:rPr/>
-              <a:t>Technical Architecture</a:t>
+              <a:t>3. Technical Architecture</a:t>
             </a:r>
           </a:p>
         </p:txBody>
@@ -7933,8 +7943,8 @@
         </p:blipFill>
         <p:spPr bwMode="auto">
           <a:xfrm>
-            <a:off x="3797300" y="1193800"/>
-            <a:ext cx="1562100" cy="2882900"/>
+            <a:off x="457200" y="2133600"/>
+            <a:ext cx="8229600" cy="990600"/>
           </a:xfrm>
           <a:prstGeom prst="rect">
             <a:avLst/>

</xml_diff>